<commit_message>
changed README and changed overview of thesis
</commit_message>
<xml_diff>
--- a/in-progress/dynamic-energy-seperation/overview.pptx
+++ b/in-progress/dynamic-energy-seperation/overview.pptx
@@ -285,7 +285,7 @@
           <a:p>
             <a:fld id="{BA2C29F9-8EC4-4A28-94D0-1519FBED630A}" type="datetimeFigureOut">
               <a:rPr lang="de-AT" smtClean="0"/>
-              <a:t>03.12.2022</a:t>
+              <a:t>05.12.2022</a:t>
             </a:fld>
             <a:endParaRPr lang="de-AT"/>
           </a:p>
@@ -513,7 +513,7 @@
           <a:p>
             <a:fld id="{BA2C29F9-8EC4-4A28-94D0-1519FBED630A}" type="datetimeFigureOut">
               <a:rPr lang="de-AT" smtClean="0"/>
-              <a:t>03.12.2022</a:t>
+              <a:t>05.12.2022</a:t>
             </a:fld>
             <a:endParaRPr lang="de-AT"/>
           </a:p>
@@ -693,7 +693,7 @@
           <a:p>
             <a:fld id="{BA2C29F9-8EC4-4A28-94D0-1519FBED630A}" type="datetimeFigureOut">
               <a:rPr lang="de-AT" smtClean="0"/>
-              <a:t>03.12.2022</a:t>
+              <a:t>05.12.2022</a:t>
             </a:fld>
             <a:endParaRPr lang="de-AT"/>
           </a:p>
@@ -863,7 +863,7 @@
           <a:p>
             <a:fld id="{BA2C29F9-8EC4-4A28-94D0-1519FBED630A}" type="datetimeFigureOut">
               <a:rPr lang="de-AT" smtClean="0"/>
-              <a:t>03.12.2022</a:t>
+              <a:t>05.12.2022</a:t>
             </a:fld>
             <a:endParaRPr lang="de-AT"/>
           </a:p>
@@ -1117,7 +1117,7 @@
           <a:p>
             <a:fld id="{BA2C29F9-8EC4-4A28-94D0-1519FBED630A}" type="datetimeFigureOut">
               <a:rPr lang="de-AT" smtClean="0"/>
-              <a:t>03.12.2022</a:t>
+              <a:t>05.12.2022</a:t>
             </a:fld>
             <a:endParaRPr lang="de-AT"/>
           </a:p>
@@ -1443,7 +1443,7 @@
           <a:p>
             <a:fld id="{BA2C29F9-8EC4-4A28-94D0-1519FBED630A}" type="datetimeFigureOut">
               <a:rPr lang="de-AT" smtClean="0"/>
-              <a:t>03.12.2022</a:t>
+              <a:t>05.12.2022</a:t>
             </a:fld>
             <a:endParaRPr lang="de-AT"/>
           </a:p>
@@ -1894,7 +1894,7 @@
           <a:p>
             <a:fld id="{BA2C29F9-8EC4-4A28-94D0-1519FBED630A}" type="datetimeFigureOut">
               <a:rPr lang="de-AT" smtClean="0"/>
-              <a:t>03.12.2022</a:t>
+              <a:t>05.12.2022</a:t>
             </a:fld>
             <a:endParaRPr lang="de-AT"/>
           </a:p>
@@ -2012,7 +2012,7 @@
           <a:p>
             <a:fld id="{BA2C29F9-8EC4-4A28-94D0-1519FBED630A}" type="datetimeFigureOut">
               <a:rPr lang="de-AT" smtClean="0"/>
-              <a:t>03.12.2022</a:t>
+              <a:t>05.12.2022</a:t>
             </a:fld>
             <a:endParaRPr lang="de-AT"/>
           </a:p>
@@ -2107,7 +2107,7 @@
           <a:p>
             <a:fld id="{BA2C29F9-8EC4-4A28-94D0-1519FBED630A}" type="datetimeFigureOut">
               <a:rPr lang="de-AT" smtClean="0"/>
-              <a:t>03.12.2022</a:t>
+              <a:t>05.12.2022</a:t>
             </a:fld>
             <a:endParaRPr lang="de-AT"/>
           </a:p>
@@ -2394,7 +2394,7 @@
           <a:p>
             <a:fld id="{BA2C29F9-8EC4-4A28-94D0-1519FBED630A}" type="datetimeFigureOut">
               <a:rPr lang="de-AT" smtClean="0"/>
-              <a:t>03.12.2022</a:t>
+              <a:t>05.12.2022</a:t>
             </a:fld>
             <a:endParaRPr lang="de-AT"/>
           </a:p>
@@ -2716,7 +2716,7 @@
           <a:p>
             <a:fld id="{BA2C29F9-8EC4-4A28-94D0-1519FBED630A}" type="datetimeFigureOut">
               <a:rPr lang="de-AT" smtClean="0"/>
-              <a:t>03.12.2022</a:t>
+              <a:t>05.12.2022</a:t>
             </a:fld>
             <a:endParaRPr lang="de-AT"/>
           </a:p>
@@ -2970,7 +2970,7 @@
           <a:p>
             <a:fld id="{BA2C29F9-8EC4-4A28-94D0-1519FBED630A}" type="datetimeFigureOut">
               <a:rPr lang="de-AT" smtClean="0"/>
-              <a:t>03.12.2022</a:t>
+              <a:t>05.12.2022</a:t>
             </a:fld>
             <a:endParaRPr lang="de-AT"/>
           </a:p>
@@ -8006,6 +8006,42 @@
           </a:p>
         </p:txBody>
       </p:sp>
+      <p:sp>
+        <p:nvSpPr>
+          <p:cNvPr id="2" name="TextBox 1">
+            <a:extLst>
+              <a:ext uri="{FF2B5EF4-FFF2-40B4-BE49-F238E27FC236}">
+                <a16:creationId xmlns:a16="http://schemas.microsoft.com/office/drawing/2014/main" id="{F3A22BB2-28C3-027E-DDC3-54F45C99808C}"/>
+              </a:ext>
+            </a:extLst>
+          </p:cNvPr>
+          <p:cNvSpPr txBox="1"/>
+          <p:nvPr/>
+        </p:nvSpPr>
+        <p:spPr>
+          <a:xfrm>
+            <a:off x="7871605" y="6114536"/>
+            <a:ext cx="2932981" cy="600164"/>
+          </a:xfrm>
+          <a:prstGeom prst="rect">
+            <a:avLst/>
+          </a:prstGeom>
+          <a:noFill/>
+        </p:spPr>
+        <p:txBody>
+          <a:bodyPr wrap="square" rtlCol="0">
+            <a:spAutoFit/>
+          </a:bodyPr>
+          <a:lstStyle/>
+          <a:p>
+            <a:r>
+              <a:rPr lang="de-DE" sz="1100" dirty="0"/>
+              <a:t>M4 braucht nur 6,4 kWh und bekommt diese auch zugesprochen. M2 und M3 bekommen die restlichen Anteile von M4.</a:t>
+            </a:r>
+            <a:endParaRPr lang="de-AT" sz="1100" dirty="0"/>
+          </a:p>
+        </p:txBody>
+      </p:sp>
     </p:spTree>
     <p:extLst>
       <p:ext uri="{BB962C8B-B14F-4D97-AF65-F5344CB8AC3E}">

</xml_diff>

<commit_message>
first version of seperation algorithm
</commit_message>
<xml_diff>
--- a/in-progress/dynamic-energy-seperation/overview.pptx
+++ b/in-progress/dynamic-energy-seperation/overview.pptx
@@ -11,7 +11,6 @@
     <p:sldId id="260" r:id="rId5"/>
     <p:sldId id="261" r:id="rId6"/>
     <p:sldId id="264" r:id="rId7"/>
-    <p:sldId id="265" r:id="rId8"/>
   </p:sldIdLst>
   <p:sldSz cx="12192000" cy="6858000"/>
   <p:notesSz cx="6858000" cy="9144000"/>
@@ -286,7 +285,7 @@
           <a:p>
             <a:fld id="{BA2C29F9-8EC4-4A28-94D0-1519FBED630A}" type="datetimeFigureOut">
               <a:rPr lang="de-AT" smtClean="0"/>
-              <a:t>05.12.2022</a:t>
+              <a:t>06.12.2022</a:t>
             </a:fld>
             <a:endParaRPr lang="de-AT"/>
           </a:p>
@@ -514,7 +513,7 @@
           <a:p>
             <a:fld id="{BA2C29F9-8EC4-4A28-94D0-1519FBED630A}" type="datetimeFigureOut">
               <a:rPr lang="de-AT" smtClean="0"/>
-              <a:t>05.12.2022</a:t>
+              <a:t>06.12.2022</a:t>
             </a:fld>
             <a:endParaRPr lang="de-AT"/>
           </a:p>
@@ -694,7 +693,7 @@
           <a:p>
             <a:fld id="{BA2C29F9-8EC4-4A28-94D0-1519FBED630A}" type="datetimeFigureOut">
               <a:rPr lang="de-AT" smtClean="0"/>
-              <a:t>05.12.2022</a:t>
+              <a:t>06.12.2022</a:t>
             </a:fld>
             <a:endParaRPr lang="de-AT"/>
           </a:p>
@@ -864,7 +863,7 @@
           <a:p>
             <a:fld id="{BA2C29F9-8EC4-4A28-94D0-1519FBED630A}" type="datetimeFigureOut">
               <a:rPr lang="de-AT" smtClean="0"/>
-              <a:t>05.12.2022</a:t>
+              <a:t>06.12.2022</a:t>
             </a:fld>
             <a:endParaRPr lang="de-AT"/>
           </a:p>
@@ -1118,7 +1117,7 @@
           <a:p>
             <a:fld id="{BA2C29F9-8EC4-4A28-94D0-1519FBED630A}" type="datetimeFigureOut">
               <a:rPr lang="de-AT" smtClean="0"/>
-              <a:t>05.12.2022</a:t>
+              <a:t>06.12.2022</a:t>
             </a:fld>
             <a:endParaRPr lang="de-AT"/>
           </a:p>
@@ -1444,7 +1443,7 @@
           <a:p>
             <a:fld id="{BA2C29F9-8EC4-4A28-94D0-1519FBED630A}" type="datetimeFigureOut">
               <a:rPr lang="de-AT" smtClean="0"/>
-              <a:t>05.12.2022</a:t>
+              <a:t>06.12.2022</a:t>
             </a:fld>
             <a:endParaRPr lang="de-AT"/>
           </a:p>
@@ -1895,7 +1894,7 @@
           <a:p>
             <a:fld id="{BA2C29F9-8EC4-4A28-94D0-1519FBED630A}" type="datetimeFigureOut">
               <a:rPr lang="de-AT" smtClean="0"/>
-              <a:t>05.12.2022</a:t>
+              <a:t>06.12.2022</a:t>
             </a:fld>
             <a:endParaRPr lang="de-AT"/>
           </a:p>
@@ -2013,7 +2012,7 @@
           <a:p>
             <a:fld id="{BA2C29F9-8EC4-4A28-94D0-1519FBED630A}" type="datetimeFigureOut">
               <a:rPr lang="de-AT" smtClean="0"/>
-              <a:t>05.12.2022</a:t>
+              <a:t>06.12.2022</a:t>
             </a:fld>
             <a:endParaRPr lang="de-AT"/>
           </a:p>
@@ -2108,7 +2107,7 @@
           <a:p>
             <a:fld id="{BA2C29F9-8EC4-4A28-94D0-1519FBED630A}" type="datetimeFigureOut">
               <a:rPr lang="de-AT" smtClean="0"/>
-              <a:t>05.12.2022</a:t>
+              <a:t>06.12.2022</a:t>
             </a:fld>
             <a:endParaRPr lang="de-AT"/>
           </a:p>
@@ -2395,7 +2394,7 @@
           <a:p>
             <a:fld id="{BA2C29F9-8EC4-4A28-94D0-1519FBED630A}" type="datetimeFigureOut">
               <a:rPr lang="de-AT" smtClean="0"/>
-              <a:t>05.12.2022</a:t>
+              <a:t>06.12.2022</a:t>
             </a:fld>
             <a:endParaRPr lang="de-AT"/>
           </a:p>
@@ -2717,7 +2716,7 @@
           <a:p>
             <a:fld id="{BA2C29F9-8EC4-4A28-94D0-1519FBED630A}" type="datetimeFigureOut">
               <a:rPr lang="de-AT" smtClean="0"/>
-              <a:t>05.12.2022</a:t>
+              <a:t>06.12.2022</a:t>
             </a:fld>
             <a:endParaRPr lang="de-AT"/>
           </a:p>
@@ -2971,7 +2970,7 @@
           <a:p>
             <a:fld id="{BA2C29F9-8EC4-4A28-94D0-1519FBED630A}" type="datetimeFigureOut">
               <a:rPr lang="de-AT" smtClean="0"/>
-              <a:t>05.12.2022</a:t>
+              <a:t>06.12.2022</a:t>
             </a:fld>
             <a:endParaRPr lang="de-AT"/>
           </a:p>
@@ -5585,8 +5584,8 @@
           </a:p>
         </p:txBody>
       </p:sp>
-      <mc:AlternateContent xmlns:mc="http://schemas.openxmlformats.org/markup-compatibility/2006">
-        <mc:Choice xmlns:a14="http://schemas.microsoft.com/office/drawing/2010/main" Requires="a14">
+      <mc:AlternateContent xmlns:mc="http://schemas.openxmlformats.org/markup-compatibility/2006" xmlns:a14="http://schemas.microsoft.com/office/drawing/2010/main">
+        <mc:Choice Requires="a14">
           <p:sp>
             <p:nvSpPr>
               <p:cNvPr id="5" name="TextBox 4">
@@ -5769,13 +5768,7 @@
                             <a:rPr lang="de-AT" sz="1100" b="0" i="1" smtClean="0">
                               <a:latin typeface="Cambria Math" panose="02040503050406030204" pitchFamily="18" charset="0"/>
                             </a:rPr>
-                            <m:t>𝐺𝑒𝑠𝑎𝑚𝑡</m:t>
-                          </m:r>
-                          <m:r>
-                            <a:rPr lang="de-AT" sz="1100" b="0" i="1" smtClean="0">
-                              <a:latin typeface="Cambria Math" panose="02040503050406030204" pitchFamily="18" charset="0"/>
-                            </a:rPr>
-                            <m:t>𝑙𝑎𝑠𝑡</m:t>
+                            <m:t>𝐺𝑒𝑠𝑎𝑚𝑡𝑙𝑎𝑠𝑡</m:t>
                           </m:r>
                         </m:den>
                       </m:f>
@@ -6064,7 +6057,7 @@
             </p:txBody>
           </p:sp>
         </mc:Choice>
-        <mc:Fallback>
+        <mc:Fallback xmlns="">
           <p:sp>
             <p:nvSpPr>
               <p:cNvPr id="5" name="TextBox 4">
@@ -7651,8 +7644,8 @@
           </a:p>
         </p:txBody>
       </p:sp>
-      <mc:AlternateContent xmlns:mc="http://schemas.openxmlformats.org/markup-compatibility/2006">
-        <mc:Choice xmlns:a14="http://schemas.microsoft.com/office/drawing/2010/main" Requires="a14">
+      <mc:AlternateContent xmlns:mc="http://schemas.openxmlformats.org/markup-compatibility/2006" xmlns:a14="http://schemas.microsoft.com/office/drawing/2010/main">
+        <mc:Choice Requires="a14">
           <p:sp>
             <p:nvSpPr>
               <p:cNvPr id="97" name="TextBox 96">
@@ -7835,13 +7828,7 @@
                             <a:rPr lang="de-AT" sz="1100" b="0" i="1" smtClean="0">
                               <a:latin typeface="Cambria Math" panose="02040503050406030204" pitchFamily="18" charset="0"/>
                             </a:rPr>
-                            <m:t>𝐺𝑒𝑠𝑎𝑚𝑡</m:t>
-                          </m:r>
-                          <m:r>
-                            <a:rPr lang="de-AT" sz="1100" b="0" i="1" smtClean="0">
-                              <a:latin typeface="Cambria Math" panose="02040503050406030204" pitchFamily="18" charset="0"/>
-                            </a:rPr>
-                            <m:t>𝑙𝑎𝑠𝑡</m:t>
+                            <m:t>𝐺𝑒𝑠𝑎𝑚𝑡𝑙𝑎𝑠𝑡</m:t>
                           </m:r>
                         </m:den>
                       </m:f>
@@ -8105,7 +8092,7 @@
             </p:txBody>
           </p:sp>
         </mc:Choice>
-        <mc:Fallback>
+        <mc:Fallback xmlns="">
           <p:sp>
             <p:nvSpPr>
               <p:cNvPr id="97" name="TextBox 96">
@@ -8307,2091 +8294,6 @@
     <p:extLst>
       <p:ext uri="{BB962C8B-B14F-4D97-AF65-F5344CB8AC3E}">
         <p14:creationId xmlns:p14="http://schemas.microsoft.com/office/powerpoint/2010/main" val="516834039"/>
-      </p:ext>
-    </p:extLst>
-  </p:cSld>
-  <p:clrMapOvr>
-    <a:masterClrMapping/>
-  </p:clrMapOvr>
-</p:sld>
-</file>
-
-<file path=ppt/slides/slide7.xml><?xml version="1.0" encoding="utf-8"?>
-<p:sld xmlns:a="http://schemas.openxmlformats.org/drawingml/2006/main" xmlns:r="http://schemas.openxmlformats.org/officeDocument/2006/relationships" xmlns:p="http://schemas.openxmlformats.org/presentationml/2006/main">
-  <p:cSld>
-    <p:spTree>
-      <p:nvGrpSpPr>
-        <p:cNvPr id="1" name=""/>
-        <p:cNvGrpSpPr/>
-        <p:nvPr/>
-      </p:nvGrpSpPr>
-      <p:grpSpPr>
-        <a:xfrm>
-          <a:off x="0" y="0"/>
-          <a:ext cx="0" cy="0"/>
-          <a:chOff x="0" y="0"/>
-          <a:chExt cx="0" cy="0"/>
-        </a:xfrm>
-      </p:grpSpPr>
-      <p:sp>
-        <p:nvSpPr>
-          <p:cNvPr id="4" name="Rectangle 3">
-            <a:extLst>
-              <a:ext uri="{FF2B5EF4-FFF2-40B4-BE49-F238E27FC236}">
-                <a16:creationId xmlns:a16="http://schemas.microsoft.com/office/drawing/2014/main" id="{AF35FD99-BAF3-106D-2FF9-20D83FC38DCC}"/>
-              </a:ext>
-            </a:extLst>
-          </p:cNvPr>
-          <p:cNvSpPr/>
-          <p:nvPr/>
-        </p:nvSpPr>
-        <p:spPr>
-          <a:xfrm>
-            <a:off x="2865408" y="3209025"/>
-            <a:ext cx="1457864" cy="439947"/>
-          </a:xfrm>
-          <a:prstGeom prst="rect">
-            <a:avLst/>
-          </a:prstGeom>
-        </p:spPr>
-        <p:style>
-          <a:lnRef idx="2">
-            <a:schemeClr val="accent1">
-              <a:shade val="50000"/>
-            </a:schemeClr>
-          </a:lnRef>
-          <a:fillRef idx="1">
-            <a:schemeClr val="accent1"/>
-          </a:fillRef>
-          <a:effectRef idx="0">
-            <a:schemeClr val="accent1"/>
-          </a:effectRef>
-          <a:fontRef idx="minor">
-            <a:schemeClr val="lt1"/>
-          </a:fontRef>
-        </p:style>
-        <p:txBody>
-          <a:bodyPr rtlCol="0" anchor="ctr"/>
-          <a:lstStyle/>
-          <a:p>
-            <a:pPr algn="ctr"/>
-            <a:r>
-              <a:rPr lang="de-AT" dirty="0"/>
-              <a:t>Erzeugung</a:t>
-            </a:r>
-          </a:p>
-        </p:txBody>
-      </p:sp>
-      <p:sp>
-        <p:nvSpPr>
-          <p:cNvPr id="41" name="Rectangle 40">
-            <a:extLst>
-              <a:ext uri="{FF2B5EF4-FFF2-40B4-BE49-F238E27FC236}">
-                <a16:creationId xmlns:a16="http://schemas.microsoft.com/office/drawing/2014/main" id="{D52C2A86-B145-B24B-0092-3AE3DD65A56C}"/>
-              </a:ext>
-            </a:extLst>
-          </p:cNvPr>
-          <p:cNvSpPr/>
-          <p:nvPr/>
-        </p:nvSpPr>
-        <p:spPr>
-          <a:xfrm>
-            <a:off x="5367068" y="1035170"/>
-            <a:ext cx="1457864" cy="4787660"/>
-          </a:xfrm>
-          <a:prstGeom prst="rect">
-            <a:avLst/>
-          </a:prstGeom>
-        </p:spPr>
-        <p:style>
-          <a:lnRef idx="2">
-            <a:schemeClr val="accent1">
-              <a:shade val="50000"/>
-            </a:schemeClr>
-          </a:lnRef>
-          <a:fillRef idx="1">
-            <a:schemeClr val="accent1"/>
-          </a:fillRef>
-          <a:effectRef idx="0">
-            <a:schemeClr val="accent1"/>
-          </a:effectRef>
-          <a:fontRef idx="minor">
-            <a:schemeClr val="lt1"/>
-          </a:fontRef>
-        </p:style>
-        <p:txBody>
-          <a:bodyPr rtlCol="0" anchor="ctr"/>
-          <a:lstStyle/>
-          <a:p>
-            <a:pPr algn="ctr"/>
-            <a:r>
-              <a:rPr lang="de-AT" dirty="0"/>
-              <a:t>Aufteilung</a:t>
-            </a:r>
-          </a:p>
-        </p:txBody>
-      </p:sp>
-      <p:cxnSp>
-        <p:nvCxnSpPr>
-          <p:cNvPr id="44" name="Straight Arrow Connector 43">
-            <a:extLst>
-              <a:ext uri="{FF2B5EF4-FFF2-40B4-BE49-F238E27FC236}">
-                <a16:creationId xmlns:a16="http://schemas.microsoft.com/office/drawing/2014/main" id="{AC2755BD-B438-B72F-C379-0AC356E3532C}"/>
-              </a:ext>
-            </a:extLst>
-          </p:cNvPr>
-          <p:cNvCxnSpPr>
-            <a:cxnSpLocks/>
-            <a:stCxn id="4" idx="3"/>
-            <a:endCxn id="41" idx="1"/>
-          </p:cNvCxnSpPr>
-          <p:nvPr/>
-        </p:nvCxnSpPr>
-        <p:spPr>
-          <a:xfrm>
-            <a:off x="4323272" y="3428999"/>
-            <a:ext cx="1043796" cy="1"/>
-          </a:xfrm>
-          <a:prstGeom prst="straightConnector1">
-            <a:avLst/>
-          </a:prstGeom>
-          <a:ln>
-            <a:tailEnd type="triangle"/>
-          </a:ln>
-        </p:spPr>
-        <p:style>
-          <a:lnRef idx="1">
-            <a:schemeClr val="accent1"/>
-          </a:lnRef>
-          <a:fillRef idx="0">
-            <a:schemeClr val="accent1"/>
-          </a:fillRef>
-          <a:effectRef idx="0">
-            <a:schemeClr val="accent1"/>
-          </a:effectRef>
-          <a:fontRef idx="minor">
-            <a:schemeClr val="tx1"/>
-          </a:fontRef>
-        </p:style>
-      </p:cxnSp>
-      <p:sp>
-        <p:nvSpPr>
-          <p:cNvPr id="45" name="TextBox 44">
-            <a:extLst>
-              <a:ext uri="{FF2B5EF4-FFF2-40B4-BE49-F238E27FC236}">
-                <a16:creationId xmlns:a16="http://schemas.microsoft.com/office/drawing/2014/main" id="{49BD545F-1FA3-7133-C693-98E09353068D}"/>
-              </a:ext>
-            </a:extLst>
-          </p:cNvPr>
-          <p:cNvSpPr txBox="1"/>
-          <p:nvPr/>
-        </p:nvSpPr>
-        <p:spPr>
-          <a:xfrm>
-            <a:off x="4501192" y="3198327"/>
-            <a:ext cx="687956" cy="261610"/>
-          </a:xfrm>
-          <a:prstGeom prst="rect">
-            <a:avLst/>
-          </a:prstGeom>
-          <a:noFill/>
-        </p:spPr>
-        <p:txBody>
-          <a:bodyPr wrap="square" rtlCol="0">
-            <a:spAutoFit/>
-          </a:bodyPr>
-          <a:lstStyle/>
-          <a:p>
-            <a:r>
-              <a:rPr lang="de-AT" sz="1100" dirty="0"/>
-              <a:t>12 kWh</a:t>
-            </a:r>
-          </a:p>
-        </p:txBody>
-      </p:sp>
-      <p:sp>
-        <p:nvSpPr>
-          <p:cNvPr id="72" name="Action Button: Go Home 71">
-            <a:hlinkClick r:id="" action="ppaction://noaction" highlightClick="1"/>
-            <a:extLst>
-              <a:ext uri="{FF2B5EF4-FFF2-40B4-BE49-F238E27FC236}">
-                <a16:creationId xmlns:a16="http://schemas.microsoft.com/office/drawing/2014/main" id="{D644A587-C958-8C74-F397-857D995DDAF9}"/>
-              </a:ext>
-            </a:extLst>
-          </p:cNvPr>
-          <p:cNvSpPr/>
-          <p:nvPr/>
-        </p:nvSpPr>
-        <p:spPr>
-          <a:xfrm>
-            <a:off x="9138969" y="1291874"/>
-            <a:ext cx="655608" cy="728095"/>
-          </a:xfrm>
-          <a:prstGeom prst="actionButtonHome">
-            <a:avLst/>
-          </a:prstGeom>
-        </p:spPr>
-        <p:style>
-          <a:lnRef idx="2">
-            <a:schemeClr val="accent1">
-              <a:shade val="50000"/>
-            </a:schemeClr>
-          </a:lnRef>
-          <a:fillRef idx="1">
-            <a:schemeClr val="accent1"/>
-          </a:fillRef>
-          <a:effectRef idx="0">
-            <a:schemeClr val="accent1"/>
-          </a:effectRef>
-          <a:fontRef idx="minor">
-            <a:schemeClr val="lt1"/>
-          </a:fontRef>
-        </p:style>
-        <p:txBody>
-          <a:bodyPr rtlCol="0" anchor="ctr"/>
-          <a:lstStyle/>
-          <a:p>
-            <a:pPr algn="ctr"/>
-            <a:endParaRPr lang="de-AT"/>
-          </a:p>
-        </p:txBody>
-      </p:sp>
-      <p:sp>
-        <p:nvSpPr>
-          <p:cNvPr id="73" name="Rectangle 72">
-            <a:extLst>
-              <a:ext uri="{FF2B5EF4-FFF2-40B4-BE49-F238E27FC236}">
-                <a16:creationId xmlns:a16="http://schemas.microsoft.com/office/drawing/2014/main" id="{F498A6CB-74C1-81A3-72FC-9F4FF0C9AAC4}"/>
-              </a:ext>
-            </a:extLst>
-          </p:cNvPr>
-          <p:cNvSpPr/>
-          <p:nvPr/>
-        </p:nvSpPr>
-        <p:spPr>
-          <a:xfrm>
-            <a:off x="7868728" y="1291874"/>
-            <a:ext cx="1200508" cy="214225"/>
-          </a:xfrm>
-          <a:prstGeom prst="rect">
-            <a:avLst/>
-          </a:prstGeom>
-        </p:spPr>
-        <p:style>
-          <a:lnRef idx="2">
-            <a:schemeClr val="accent1">
-              <a:shade val="50000"/>
-            </a:schemeClr>
-          </a:lnRef>
-          <a:fillRef idx="1">
-            <a:schemeClr val="accent1"/>
-          </a:fillRef>
-          <a:effectRef idx="0">
-            <a:schemeClr val="accent1"/>
-          </a:effectRef>
-          <a:fontRef idx="minor">
-            <a:schemeClr val="lt1"/>
-          </a:fontRef>
-        </p:style>
-        <p:txBody>
-          <a:bodyPr rtlCol="0" anchor="ctr"/>
-          <a:lstStyle/>
-          <a:p>
-            <a:pPr algn="ctr"/>
-            <a:r>
-              <a:rPr lang="de-AT" sz="1200" dirty="0"/>
-              <a:t>Lastprofil</a:t>
-            </a:r>
-          </a:p>
-        </p:txBody>
-      </p:sp>
-      <p:sp>
-        <p:nvSpPr>
-          <p:cNvPr id="74" name="Rectangle 73">
-            <a:extLst>
-              <a:ext uri="{FF2B5EF4-FFF2-40B4-BE49-F238E27FC236}">
-                <a16:creationId xmlns:a16="http://schemas.microsoft.com/office/drawing/2014/main" id="{39DD4034-E253-E8C3-224E-B41265103ABC}"/>
-              </a:ext>
-            </a:extLst>
-          </p:cNvPr>
-          <p:cNvSpPr/>
-          <p:nvPr/>
-        </p:nvSpPr>
-        <p:spPr>
-          <a:xfrm>
-            <a:off x="7868728" y="1549224"/>
-            <a:ext cx="1200508" cy="214225"/>
-          </a:xfrm>
-          <a:prstGeom prst="rect">
-            <a:avLst/>
-          </a:prstGeom>
-        </p:spPr>
-        <p:style>
-          <a:lnRef idx="2">
-            <a:schemeClr val="accent1">
-              <a:shade val="50000"/>
-            </a:schemeClr>
-          </a:lnRef>
-          <a:fillRef idx="1">
-            <a:schemeClr val="accent1"/>
-          </a:fillRef>
-          <a:effectRef idx="0">
-            <a:schemeClr val="accent1"/>
-          </a:effectRef>
-          <a:fontRef idx="minor">
-            <a:schemeClr val="lt1"/>
-          </a:fontRef>
-        </p:style>
-        <p:txBody>
-          <a:bodyPr rtlCol="0" anchor="ctr"/>
-          <a:lstStyle/>
-          <a:p>
-            <a:pPr algn="ctr"/>
-            <a:r>
-              <a:rPr lang="de-AT" sz="1200" dirty="0"/>
-              <a:t>Flexibilität</a:t>
-            </a:r>
-          </a:p>
-        </p:txBody>
-      </p:sp>
-      <p:cxnSp>
-        <p:nvCxnSpPr>
-          <p:cNvPr id="75" name="Straight Arrow Connector 74">
-            <a:extLst>
-              <a:ext uri="{FF2B5EF4-FFF2-40B4-BE49-F238E27FC236}">
-                <a16:creationId xmlns:a16="http://schemas.microsoft.com/office/drawing/2014/main" id="{CF674E78-8E82-58D9-85D1-971EF7FA21FE}"/>
-              </a:ext>
-            </a:extLst>
-          </p:cNvPr>
-          <p:cNvCxnSpPr>
-            <a:cxnSpLocks/>
-            <a:stCxn id="73" idx="1"/>
-          </p:cNvCxnSpPr>
-          <p:nvPr/>
-        </p:nvCxnSpPr>
-        <p:spPr>
-          <a:xfrm flipH="1">
-            <a:off x="6824932" y="1398987"/>
-            <a:ext cx="1043796" cy="0"/>
-          </a:xfrm>
-          <a:prstGeom prst="straightConnector1">
-            <a:avLst/>
-          </a:prstGeom>
-          <a:ln>
-            <a:tailEnd type="triangle"/>
-          </a:ln>
-        </p:spPr>
-        <p:style>
-          <a:lnRef idx="1">
-            <a:schemeClr val="accent1"/>
-          </a:lnRef>
-          <a:fillRef idx="0">
-            <a:schemeClr val="accent1"/>
-          </a:fillRef>
-          <a:effectRef idx="0">
-            <a:schemeClr val="accent1"/>
-          </a:effectRef>
-          <a:fontRef idx="minor">
-            <a:schemeClr val="tx1"/>
-          </a:fontRef>
-        </p:style>
-      </p:cxnSp>
-      <p:cxnSp>
-        <p:nvCxnSpPr>
-          <p:cNvPr id="76" name="Straight Arrow Connector 75">
-            <a:extLst>
-              <a:ext uri="{FF2B5EF4-FFF2-40B4-BE49-F238E27FC236}">
-                <a16:creationId xmlns:a16="http://schemas.microsoft.com/office/drawing/2014/main" id="{AA548A45-5676-BAB1-48B4-EDFE0F0461DE}"/>
-              </a:ext>
-            </a:extLst>
-          </p:cNvPr>
-          <p:cNvCxnSpPr>
-            <a:cxnSpLocks/>
-            <a:endCxn id="5" idx="1"/>
-          </p:cNvCxnSpPr>
-          <p:nvPr/>
-        </p:nvCxnSpPr>
-        <p:spPr>
-          <a:xfrm>
-            <a:off x="6824932" y="1912857"/>
-            <a:ext cx="1043796" cy="0"/>
-          </a:xfrm>
-          <a:prstGeom prst="straightConnector1">
-            <a:avLst/>
-          </a:prstGeom>
-          <a:ln>
-            <a:tailEnd type="triangle"/>
-          </a:ln>
-        </p:spPr>
-        <p:style>
-          <a:lnRef idx="1">
-            <a:schemeClr val="accent1"/>
-          </a:lnRef>
-          <a:fillRef idx="0">
-            <a:schemeClr val="accent1"/>
-          </a:fillRef>
-          <a:effectRef idx="0">
-            <a:schemeClr val="accent1"/>
-          </a:effectRef>
-          <a:fontRef idx="minor">
-            <a:schemeClr val="tx1"/>
-          </a:fontRef>
-        </p:style>
-      </p:cxnSp>
-      <p:sp>
-        <p:nvSpPr>
-          <p:cNvPr id="77" name="TextBox 76">
-            <a:extLst>
-              <a:ext uri="{FF2B5EF4-FFF2-40B4-BE49-F238E27FC236}">
-                <a16:creationId xmlns:a16="http://schemas.microsoft.com/office/drawing/2014/main" id="{9C9FB075-4236-3AAA-91A9-22C55E1625B0}"/>
-              </a:ext>
-            </a:extLst>
-          </p:cNvPr>
-          <p:cNvSpPr txBox="1"/>
-          <p:nvPr/>
-        </p:nvSpPr>
-        <p:spPr>
-          <a:xfrm>
-            <a:off x="7002852" y="1189223"/>
-            <a:ext cx="687956" cy="261610"/>
-          </a:xfrm>
-          <a:prstGeom prst="rect">
-            <a:avLst/>
-          </a:prstGeom>
-          <a:noFill/>
-        </p:spPr>
-        <p:txBody>
-          <a:bodyPr wrap="square" rtlCol="0">
-            <a:spAutoFit/>
-          </a:bodyPr>
-          <a:lstStyle/>
-          <a:p>
-            <a:r>
-              <a:rPr lang="de-AT" sz="1100" dirty="0"/>
-              <a:t>0 Wh</a:t>
-            </a:r>
-          </a:p>
-        </p:txBody>
-      </p:sp>
-      <p:sp>
-        <p:nvSpPr>
-          <p:cNvPr id="78" name="TextBox 77">
-            <a:extLst>
-              <a:ext uri="{FF2B5EF4-FFF2-40B4-BE49-F238E27FC236}">
-                <a16:creationId xmlns:a16="http://schemas.microsoft.com/office/drawing/2014/main" id="{4F1E3527-3D92-B3FF-250D-E13B924B6723}"/>
-              </a:ext>
-            </a:extLst>
-          </p:cNvPr>
-          <p:cNvSpPr txBox="1"/>
-          <p:nvPr/>
-        </p:nvSpPr>
-        <p:spPr>
-          <a:xfrm>
-            <a:off x="7002852" y="1880810"/>
-            <a:ext cx="687956" cy="261610"/>
-          </a:xfrm>
-          <a:prstGeom prst="rect">
-            <a:avLst/>
-          </a:prstGeom>
-          <a:noFill/>
-        </p:spPr>
-        <p:txBody>
-          <a:bodyPr wrap="square" rtlCol="0">
-            <a:spAutoFit/>
-          </a:bodyPr>
-          <a:lstStyle/>
-          <a:p>
-            <a:r>
-              <a:rPr lang="de-AT" sz="1100" dirty="0"/>
-              <a:t>0 Wh</a:t>
-            </a:r>
-          </a:p>
-        </p:txBody>
-      </p:sp>
-      <p:sp>
-        <p:nvSpPr>
-          <p:cNvPr id="93" name="TextBox 92">
-            <a:extLst>
-              <a:ext uri="{FF2B5EF4-FFF2-40B4-BE49-F238E27FC236}">
-                <a16:creationId xmlns:a16="http://schemas.microsoft.com/office/drawing/2014/main" id="{F0D44F2D-F049-7EA8-CB47-FBDDFCC73B0E}"/>
-              </a:ext>
-            </a:extLst>
-          </p:cNvPr>
-          <p:cNvSpPr txBox="1"/>
-          <p:nvPr/>
-        </p:nvSpPr>
-        <p:spPr>
-          <a:xfrm>
-            <a:off x="9841300" y="1471255"/>
-            <a:ext cx="543464" cy="369332"/>
-          </a:xfrm>
-          <a:prstGeom prst="rect">
-            <a:avLst/>
-          </a:prstGeom>
-          <a:noFill/>
-        </p:spPr>
-        <p:txBody>
-          <a:bodyPr wrap="square" rtlCol="0">
-            <a:spAutoFit/>
-          </a:bodyPr>
-          <a:lstStyle/>
-          <a:p>
-            <a:r>
-              <a:rPr lang="de-AT" dirty="0"/>
-              <a:t>M1</a:t>
-            </a:r>
-          </a:p>
-        </p:txBody>
-      </p:sp>
-      <p:sp>
-        <p:nvSpPr>
-          <p:cNvPr id="2" name="Title 1">
-            <a:extLst>
-              <a:ext uri="{FF2B5EF4-FFF2-40B4-BE49-F238E27FC236}">
-                <a16:creationId xmlns:a16="http://schemas.microsoft.com/office/drawing/2014/main" id="{1EA492F9-BF65-4584-13C3-4EAC1DF4DFE1}"/>
-              </a:ext>
-            </a:extLst>
-          </p:cNvPr>
-          <p:cNvSpPr>
-            <a:spLocks noGrp="1"/>
-          </p:cNvSpPr>
-          <p:nvPr>
-            <p:ph type="title"/>
-          </p:nvPr>
-        </p:nvSpPr>
-        <p:spPr>
-          <a:xfrm>
-            <a:off x="386048" y="238666"/>
-            <a:ext cx="9692640" cy="560062"/>
-          </a:xfrm>
-        </p:spPr>
-        <p:txBody>
-          <a:bodyPr>
-            <a:normAutofit fontScale="90000"/>
-          </a:bodyPr>
-          <a:lstStyle/>
-          <a:p>
-            <a:r>
-              <a:rPr lang="de-AT" sz="3600" dirty="0"/>
-              <a:t>Aufteilung inkl. Flexibilität (1/4)</a:t>
-            </a:r>
-          </a:p>
-        </p:txBody>
-      </p:sp>
-      <p:sp>
-        <p:nvSpPr>
-          <p:cNvPr id="5" name="Rectangle 4">
-            <a:extLst>
-              <a:ext uri="{FF2B5EF4-FFF2-40B4-BE49-F238E27FC236}">
-                <a16:creationId xmlns:a16="http://schemas.microsoft.com/office/drawing/2014/main" id="{9F53D79F-0BA2-95F6-ED1F-4CBE3936F66B}"/>
-              </a:ext>
-            </a:extLst>
-          </p:cNvPr>
-          <p:cNvSpPr/>
-          <p:nvPr/>
-        </p:nvSpPr>
-        <p:spPr>
-          <a:xfrm>
-            <a:off x="7868728" y="1805744"/>
-            <a:ext cx="1200508" cy="214225"/>
-          </a:xfrm>
-          <a:prstGeom prst="rect">
-            <a:avLst/>
-          </a:prstGeom>
-        </p:spPr>
-        <p:style>
-          <a:lnRef idx="2">
-            <a:schemeClr val="accent1">
-              <a:shade val="50000"/>
-            </a:schemeClr>
-          </a:lnRef>
-          <a:fillRef idx="1">
-            <a:schemeClr val="accent1"/>
-          </a:fillRef>
-          <a:effectRef idx="0">
-            <a:schemeClr val="accent1"/>
-          </a:effectRef>
-          <a:fontRef idx="minor">
-            <a:schemeClr val="lt1"/>
-          </a:fontRef>
-        </p:style>
-        <p:txBody>
-          <a:bodyPr rtlCol="0" anchor="ctr"/>
-          <a:lstStyle/>
-          <a:p>
-            <a:pPr algn="ctr"/>
-            <a:r>
-              <a:rPr lang="de-AT" sz="1200" dirty="0"/>
-              <a:t>Zuspruch</a:t>
-            </a:r>
-          </a:p>
-        </p:txBody>
-      </p:sp>
-      <p:cxnSp>
-        <p:nvCxnSpPr>
-          <p:cNvPr id="12" name="Straight Arrow Connector 11">
-            <a:extLst>
-              <a:ext uri="{FF2B5EF4-FFF2-40B4-BE49-F238E27FC236}">
-                <a16:creationId xmlns:a16="http://schemas.microsoft.com/office/drawing/2014/main" id="{C468427C-77F3-EC0D-E8BF-F74BFE069495}"/>
-              </a:ext>
-            </a:extLst>
-          </p:cNvPr>
-          <p:cNvCxnSpPr>
-            <a:cxnSpLocks/>
-          </p:cNvCxnSpPr>
-          <p:nvPr/>
-        </p:nvCxnSpPr>
-        <p:spPr>
-          <a:xfrm flipH="1">
-            <a:off x="6824932" y="1657239"/>
-            <a:ext cx="1043796" cy="0"/>
-          </a:xfrm>
-          <a:prstGeom prst="straightConnector1">
-            <a:avLst/>
-          </a:prstGeom>
-          <a:ln>
-            <a:tailEnd type="triangle"/>
-          </a:ln>
-        </p:spPr>
-        <p:style>
-          <a:lnRef idx="1">
-            <a:schemeClr val="accent1"/>
-          </a:lnRef>
-          <a:fillRef idx="0">
-            <a:schemeClr val="accent1"/>
-          </a:fillRef>
-          <a:effectRef idx="0">
-            <a:schemeClr val="accent1"/>
-          </a:effectRef>
-          <a:fontRef idx="minor">
-            <a:schemeClr val="tx1"/>
-          </a:fontRef>
-        </p:style>
-      </p:cxnSp>
-      <p:sp>
-        <p:nvSpPr>
-          <p:cNvPr id="13" name="TextBox 12">
-            <a:extLst>
-              <a:ext uri="{FF2B5EF4-FFF2-40B4-BE49-F238E27FC236}">
-                <a16:creationId xmlns:a16="http://schemas.microsoft.com/office/drawing/2014/main" id="{7BA475B9-A96F-DDA4-CEE1-55579421F17A}"/>
-              </a:ext>
-            </a:extLst>
-          </p:cNvPr>
-          <p:cNvSpPr txBox="1"/>
-          <p:nvPr/>
-        </p:nvSpPr>
-        <p:spPr>
-          <a:xfrm>
-            <a:off x="7002852" y="1441125"/>
-            <a:ext cx="687956" cy="261610"/>
-          </a:xfrm>
-          <a:prstGeom prst="rect">
-            <a:avLst/>
-          </a:prstGeom>
-          <a:noFill/>
-        </p:spPr>
-        <p:txBody>
-          <a:bodyPr wrap="square" rtlCol="0">
-            <a:spAutoFit/>
-          </a:bodyPr>
-          <a:lstStyle/>
-          <a:p>
-            <a:r>
-              <a:rPr lang="de-AT" sz="1100" dirty="0"/>
-              <a:t>+1 kWh</a:t>
-            </a:r>
-          </a:p>
-        </p:txBody>
-      </p:sp>
-      <p:sp>
-        <p:nvSpPr>
-          <p:cNvPr id="38" name="Action Button: Go Home 37">
-            <a:hlinkClick r:id="" action="ppaction://noaction" highlightClick="1"/>
-            <a:extLst>
-              <a:ext uri="{FF2B5EF4-FFF2-40B4-BE49-F238E27FC236}">
-                <a16:creationId xmlns:a16="http://schemas.microsoft.com/office/drawing/2014/main" id="{8A0F1E23-455C-7F46-1780-5BB74F5E4E33}"/>
-              </a:ext>
-            </a:extLst>
-          </p:cNvPr>
-          <p:cNvSpPr/>
-          <p:nvPr/>
-        </p:nvSpPr>
-        <p:spPr>
-          <a:xfrm>
-            <a:off x="9138969" y="2460397"/>
-            <a:ext cx="655608" cy="728095"/>
-          </a:xfrm>
-          <a:prstGeom prst="actionButtonHome">
-            <a:avLst/>
-          </a:prstGeom>
-        </p:spPr>
-        <p:style>
-          <a:lnRef idx="2">
-            <a:schemeClr val="accent1">
-              <a:shade val="50000"/>
-            </a:schemeClr>
-          </a:lnRef>
-          <a:fillRef idx="1">
-            <a:schemeClr val="accent1"/>
-          </a:fillRef>
-          <a:effectRef idx="0">
-            <a:schemeClr val="accent1"/>
-          </a:effectRef>
-          <a:fontRef idx="minor">
-            <a:schemeClr val="lt1"/>
-          </a:fontRef>
-        </p:style>
-        <p:txBody>
-          <a:bodyPr rtlCol="0" anchor="ctr"/>
-          <a:lstStyle/>
-          <a:p>
-            <a:pPr algn="ctr"/>
-            <a:endParaRPr lang="de-AT"/>
-          </a:p>
-        </p:txBody>
-      </p:sp>
-      <p:sp>
-        <p:nvSpPr>
-          <p:cNvPr id="39" name="Rectangle 38">
-            <a:extLst>
-              <a:ext uri="{FF2B5EF4-FFF2-40B4-BE49-F238E27FC236}">
-                <a16:creationId xmlns:a16="http://schemas.microsoft.com/office/drawing/2014/main" id="{43384134-2988-2BA0-ED9A-6BBCCED46F96}"/>
-              </a:ext>
-            </a:extLst>
-          </p:cNvPr>
-          <p:cNvSpPr/>
-          <p:nvPr/>
-        </p:nvSpPr>
-        <p:spPr>
-          <a:xfrm>
-            <a:off x="7868728" y="2460397"/>
-            <a:ext cx="1200508" cy="214225"/>
-          </a:xfrm>
-          <a:prstGeom prst="rect">
-            <a:avLst/>
-          </a:prstGeom>
-        </p:spPr>
-        <p:style>
-          <a:lnRef idx="2">
-            <a:schemeClr val="accent1">
-              <a:shade val="50000"/>
-            </a:schemeClr>
-          </a:lnRef>
-          <a:fillRef idx="1">
-            <a:schemeClr val="accent1"/>
-          </a:fillRef>
-          <a:effectRef idx="0">
-            <a:schemeClr val="accent1"/>
-          </a:effectRef>
-          <a:fontRef idx="minor">
-            <a:schemeClr val="lt1"/>
-          </a:fontRef>
-        </p:style>
-        <p:txBody>
-          <a:bodyPr rtlCol="0" anchor="ctr"/>
-          <a:lstStyle/>
-          <a:p>
-            <a:pPr algn="ctr"/>
-            <a:r>
-              <a:rPr lang="de-AT" sz="1200" dirty="0"/>
-              <a:t>Lastprofil</a:t>
-            </a:r>
-          </a:p>
-        </p:txBody>
-      </p:sp>
-      <p:sp>
-        <p:nvSpPr>
-          <p:cNvPr id="40" name="Rectangle 39">
-            <a:extLst>
-              <a:ext uri="{FF2B5EF4-FFF2-40B4-BE49-F238E27FC236}">
-                <a16:creationId xmlns:a16="http://schemas.microsoft.com/office/drawing/2014/main" id="{F3D8C2A5-A55F-D173-16FC-9F56CCF6A52D}"/>
-              </a:ext>
-            </a:extLst>
-          </p:cNvPr>
-          <p:cNvSpPr/>
-          <p:nvPr/>
-        </p:nvSpPr>
-        <p:spPr>
-          <a:xfrm>
-            <a:off x="7868728" y="2717747"/>
-            <a:ext cx="1200508" cy="214225"/>
-          </a:xfrm>
-          <a:prstGeom prst="rect">
-            <a:avLst/>
-          </a:prstGeom>
-        </p:spPr>
-        <p:style>
-          <a:lnRef idx="2">
-            <a:schemeClr val="accent1">
-              <a:shade val="50000"/>
-            </a:schemeClr>
-          </a:lnRef>
-          <a:fillRef idx="1">
-            <a:schemeClr val="accent1"/>
-          </a:fillRef>
-          <a:effectRef idx="0">
-            <a:schemeClr val="accent1"/>
-          </a:effectRef>
-          <a:fontRef idx="minor">
-            <a:schemeClr val="lt1"/>
-          </a:fontRef>
-        </p:style>
-        <p:txBody>
-          <a:bodyPr rtlCol="0" anchor="ctr"/>
-          <a:lstStyle/>
-          <a:p>
-            <a:pPr algn="ctr"/>
-            <a:r>
-              <a:rPr lang="de-AT" sz="1200" dirty="0"/>
-              <a:t>Flexibilität</a:t>
-            </a:r>
-          </a:p>
-        </p:txBody>
-      </p:sp>
-      <p:cxnSp>
-        <p:nvCxnSpPr>
-          <p:cNvPr id="43" name="Straight Arrow Connector 42">
-            <a:extLst>
-              <a:ext uri="{FF2B5EF4-FFF2-40B4-BE49-F238E27FC236}">
-                <a16:creationId xmlns:a16="http://schemas.microsoft.com/office/drawing/2014/main" id="{4DF1C857-E4CE-3A7F-63A5-ABE1506E86C4}"/>
-              </a:ext>
-            </a:extLst>
-          </p:cNvPr>
-          <p:cNvCxnSpPr>
-            <a:cxnSpLocks/>
-            <a:stCxn id="39" idx="1"/>
-          </p:cNvCxnSpPr>
-          <p:nvPr/>
-        </p:nvCxnSpPr>
-        <p:spPr>
-          <a:xfrm flipH="1">
-            <a:off x="6824932" y="2567510"/>
-            <a:ext cx="1043796" cy="0"/>
-          </a:xfrm>
-          <a:prstGeom prst="straightConnector1">
-            <a:avLst/>
-          </a:prstGeom>
-          <a:ln>
-            <a:tailEnd type="triangle"/>
-          </a:ln>
-        </p:spPr>
-        <p:style>
-          <a:lnRef idx="1">
-            <a:schemeClr val="accent1"/>
-          </a:lnRef>
-          <a:fillRef idx="0">
-            <a:schemeClr val="accent1"/>
-          </a:fillRef>
-          <a:effectRef idx="0">
-            <a:schemeClr val="accent1"/>
-          </a:effectRef>
-          <a:fontRef idx="minor">
-            <a:schemeClr val="tx1"/>
-          </a:fontRef>
-        </p:style>
-      </p:cxnSp>
-      <p:cxnSp>
-        <p:nvCxnSpPr>
-          <p:cNvPr id="46" name="Straight Arrow Connector 45">
-            <a:extLst>
-              <a:ext uri="{FF2B5EF4-FFF2-40B4-BE49-F238E27FC236}">
-                <a16:creationId xmlns:a16="http://schemas.microsoft.com/office/drawing/2014/main" id="{5267B904-BB4C-3C14-2560-0B99F848BDCB}"/>
-              </a:ext>
-            </a:extLst>
-          </p:cNvPr>
-          <p:cNvCxnSpPr>
-            <a:cxnSpLocks/>
-            <a:endCxn id="50" idx="1"/>
-          </p:cNvCxnSpPr>
-          <p:nvPr/>
-        </p:nvCxnSpPr>
-        <p:spPr>
-          <a:xfrm>
-            <a:off x="6824932" y="3081380"/>
-            <a:ext cx="1043796" cy="0"/>
-          </a:xfrm>
-          <a:prstGeom prst="straightConnector1">
-            <a:avLst/>
-          </a:prstGeom>
-          <a:ln>
-            <a:tailEnd type="triangle"/>
-          </a:ln>
-        </p:spPr>
-        <p:style>
-          <a:lnRef idx="1">
-            <a:schemeClr val="accent1"/>
-          </a:lnRef>
-          <a:fillRef idx="0">
-            <a:schemeClr val="accent1"/>
-          </a:fillRef>
-          <a:effectRef idx="0">
-            <a:schemeClr val="accent1"/>
-          </a:effectRef>
-          <a:fontRef idx="minor">
-            <a:schemeClr val="tx1"/>
-          </a:fontRef>
-        </p:style>
-      </p:cxnSp>
-      <p:sp>
-        <p:nvSpPr>
-          <p:cNvPr id="47" name="TextBox 46">
-            <a:extLst>
-              <a:ext uri="{FF2B5EF4-FFF2-40B4-BE49-F238E27FC236}">
-                <a16:creationId xmlns:a16="http://schemas.microsoft.com/office/drawing/2014/main" id="{E0EB6694-5743-28EE-82C3-4B08518C8DE3}"/>
-              </a:ext>
-            </a:extLst>
-          </p:cNvPr>
-          <p:cNvSpPr txBox="1"/>
-          <p:nvPr/>
-        </p:nvSpPr>
-        <p:spPr>
-          <a:xfrm>
-            <a:off x="7002852" y="2357746"/>
-            <a:ext cx="687956" cy="261610"/>
-          </a:xfrm>
-          <a:prstGeom prst="rect">
-            <a:avLst/>
-          </a:prstGeom>
-          <a:noFill/>
-        </p:spPr>
-        <p:txBody>
-          <a:bodyPr wrap="square" rtlCol="0">
-            <a:spAutoFit/>
-          </a:bodyPr>
-          <a:lstStyle/>
-          <a:p>
-            <a:r>
-              <a:rPr lang="de-AT" sz="1100" dirty="0"/>
-              <a:t>1 kWh</a:t>
-            </a:r>
-          </a:p>
-        </p:txBody>
-      </p:sp>
-      <p:sp>
-        <p:nvSpPr>
-          <p:cNvPr id="48" name="TextBox 47">
-            <a:extLst>
-              <a:ext uri="{FF2B5EF4-FFF2-40B4-BE49-F238E27FC236}">
-                <a16:creationId xmlns:a16="http://schemas.microsoft.com/office/drawing/2014/main" id="{B98FABB3-60DC-519B-FDEA-F9DDB154ACD5}"/>
-              </a:ext>
-            </a:extLst>
-          </p:cNvPr>
-          <p:cNvSpPr txBox="1"/>
-          <p:nvPr/>
-        </p:nvSpPr>
-        <p:spPr>
-          <a:xfrm>
-            <a:off x="7002852" y="3049333"/>
-            <a:ext cx="687956" cy="261610"/>
-          </a:xfrm>
-          <a:prstGeom prst="rect">
-            <a:avLst/>
-          </a:prstGeom>
-          <a:noFill/>
-        </p:spPr>
-        <p:txBody>
-          <a:bodyPr wrap="square" rtlCol="0">
-            <a:spAutoFit/>
-          </a:bodyPr>
-          <a:lstStyle/>
-          <a:p>
-            <a:r>
-              <a:rPr lang="de-AT" sz="1100" dirty="0"/>
-              <a:t>0 Wh</a:t>
-            </a:r>
-          </a:p>
-        </p:txBody>
-      </p:sp>
-      <p:sp>
-        <p:nvSpPr>
-          <p:cNvPr id="49" name="TextBox 48">
-            <a:extLst>
-              <a:ext uri="{FF2B5EF4-FFF2-40B4-BE49-F238E27FC236}">
-                <a16:creationId xmlns:a16="http://schemas.microsoft.com/office/drawing/2014/main" id="{EB295E6C-89B5-7022-369A-0409D6B10FBD}"/>
-              </a:ext>
-            </a:extLst>
-          </p:cNvPr>
-          <p:cNvSpPr txBox="1"/>
-          <p:nvPr/>
-        </p:nvSpPr>
-        <p:spPr>
-          <a:xfrm>
-            <a:off x="9841300" y="2639778"/>
-            <a:ext cx="543464" cy="369332"/>
-          </a:xfrm>
-          <a:prstGeom prst="rect">
-            <a:avLst/>
-          </a:prstGeom>
-          <a:noFill/>
-        </p:spPr>
-        <p:txBody>
-          <a:bodyPr wrap="square" rtlCol="0">
-            <a:spAutoFit/>
-          </a:bodyPr>
-          <a:lstStyle/>
-          <a:p>
-            <a:r>
-              <a:rPr lang="de-AT" dirty="0"/>
-              <a:t>M2</a:t>
-            </a:r>
-          </a:p>
-        </p:txBody>
-      </p:sp>
-      <p:sp>
-        <p:nvSpPr>
-          <p:cNvPr id="50" name="Rectangle 49">
-            <a:extLst>
-              <a:ext uri="{FF2B5EF4-FFF2-40B4-BE49-F238E27FC236}">
-                <a16:creationId xmlns:a16="http://schemas.microsoft.com/office/drawing/2014/main" id="{2505814F-0747-03A3-B350-C4BCD1CD5A35}"/>
-              </a:ext>
-            </a:extLst>
-          </p:cNvPr>
-          <p:cNvSpPr/>
-          <p:nvPr/>
-        </p:nvSpPr>
-        <p:spPr>
-          <a:xfrm>
-            <a:off x="7868728" y="2974267"/>
-            <a:ext cx="1200508" cy="214225"/>
-          </a:xfrm>
-          <a:prstGeom prst="rect">
-            <a:avLst/>
-          </a:prstGeom>
-        </p:spPr>
-        <p:style>
-          <a:lnRef idx="2">
-            <a:schemeClr val="accent1">
-              <a:shade val="50000"/>
-            </a:schemeClr>
-          </a:lnRef>
-          <a:fillRef idx="1">
-            <a:schemeClr val="accent1"/>
-          </a:fillRef>
-          <a:effectRef idx="0">
-            <a:schemeClr val="accent1"/>
-          </a:effectRef>
-          <a:fontRef idx="minor">
-            <a:schemeClr val="lt1"/>
-          </a:fontRef>
-        </p:style>
-        <p:txBody>
-          <a:bodyPr rtlCol="0" anchor="ctr"/>
-          <a:lstStyle/>
-          <a:p>
-            <a:pPr algn="ctr"/>
-            <a:r>
-              <a:rPr lang="de-AT" sz="1200" dirty="0"/>
-              <a:t>Zuspruch</a:t>
-            </a:r>
-          </a:p>
-        </p:txBody>
-      </p:sp>
-      <p:cxnSp>
-        <p:nvCxnSpPr>
-          <p:cNvPr id="51" name="Straight Arrow Connector 50">
-            <a:extLst>
-              <a:ext uri="{FF2B5EF4-FFF2-40B4-BE49-F238E27FC236}">
-                <a16:creationId xmlns:a16="http://schemas.microsoft.com/office/drawing/2014/main" id="{1DF09299-815F-4382-8835-9FB2BC0B3086}"/>
-              </a:ext>
-            </a:extLst>
-          </p:cNvPr>
-          <p:cNvCxnSpPr>
-            <a:cxnSpLocks/>
-          </p:cNvCxnSpPr>
-          <p:nvPr/>
-        </p:nvCxnSpPr>
-        <p:spPr>
-          <a:xfrm flipH="1">
-            <a:off x="6824932" y="2825762"/>
-            <a:ext cx="1043796" cy="0"/>
-          </a:xfrm>
-          <a:prstGeom prst="straightConnector1">
-            <a:avLst/>
-          </a:prstGeom>
-          <a:ln>
-            <a:tailEnd type="triangle"/>
-          </a:ln>
-        </p:spPr>
-        <p:style>
-          <a:lnRef idx="1">
-            <a:schemeClr val="accent1"/>
-          </a:lnRef>
-          <a:fillRef idx="0">
-            <a:schemeClr val="accent1"/>
-          </a:fillRef>
-          <a:effectRef idx="0">
-            <a:schemeClr val="accent1"/>
-          </a:effectRef>
-          <a:fontRef idx="minor">
-            <a:schemeClr val="tx1"/>
-          </a:fontRef>
-        </p:style>
-      </p:cxnSp>
-      <p:sp>
-        <p:nvSpPr>
-          <p:cNvPr id="53" name="TextBox 52">
-            <a:extLst>
-              <a:ext uri="{FF2B5EF4-FFF2-40B4-BE49-F238E27FC236}">
-                <a16:creationId xmlns:a16="http://schemas.microsoft.com/office/drawing/2014/main" id="{8B07859E-2285-ECB6-8164-71224D05BF7F}"/>
-              </a:ext>
-            </a:extLst>
-          </p:cNvPr>
-          <p:cNvSpPr txBox="1"/>
-          <p:nvPr/>
-        </p:nvSpPr>
-        <p:spPr>
-          <a:xfrm>
-            <a:off x="7002852" y="2609648"/>
-            <a:ext cx="687956" cy="261610"/>
-          </a:xfrm>
-          <a:prstGeom prst="rect">
-            <a:avLst/>
-          </a:prstGeom>
-          <a:noFill/>
-        </p:spPr>
-        <p:txBody>
-          <a:bodyPr wrap="square" rtlCol="0">
-            <a:spAutoFit/>
-          </a:bodyPr>
-          <a:lstStyle/>
-          <a:p>
-            <a:r>
-              <a:rPr lang="de-AT" sz="1100" dirty="0"/>
-              <a:t>+2 kWh</a:t>
-            </a:r>
-          </a:p>
-        </p:txBody>
-      </p:sp>
-      <p:sp>
-        <p:nvSpPr>
-          <p:cNvPr id="54" name="Action Button: Go Home 53">
-            <a:hlinkClick r:id="" action="ppaction://noaction" highlightClick="1"/>
-            <a:extLst>
-              <a:ext uri="{FF2B5EF4-FFF2-40B4-BE49-F238E27FC236}">
-                <a16:creationId xmlns:a16="http://schemas.microsoft.com/office/drawing/2014/main" id="{209CBB8C-32B0-8385-43D0-C507269E63FC}"/>
-              </a:ext>
-            </a:extLst>
-          </p:cNvPr>
-          <p:cNvSpPr/>
-          <p:nvPr/>
-        </p:nvSpPr>
-        <p:spPr>
-          <a:xfrm>
-            <a:off x="9138969" y="3628920"/>
-            <a:ext cx="655608" cy="728095"/>
-          </a:xfrm>
-          <a:prstGeom prst="actionButtonHome">
-            <a:avLst/>
-          </a:prstGeom>
-        </p:spPr>
-        <p:style>
-          <a:lnRef idx="2">
-            <a:schemeClr val="accent1">
-              <a:shade val="50000"/>
-            </a:schemeClr>
-          </a:lnRef>
-          <a:fillRef idx="1">
-            <a:schemeClr val="accent1"/>
-          </a:fillRef>
-          <a:effectRef idx="0">
-            <a:schemeClr val="accent1"/>
-          </a:effectRef>
-          <a:fontRef idx="minor">
-            <a:schemeClr val="lt1"/>
-          </a:fontRef>
-        </p:style>
-        <p:txBody>
-          <a:bodyPr rtlCol="0" anchor="ctr"/>
-          <a:lstStyle/>
-          <a:p>
-            <a:pPr algn="ctr"/>
-            <a:endParaRPr lang="de-AT"/>
-          </a:p>
-        </p:txBody>
-      </p:sp>
-      <p:sp>
-        <p:nvSpPr>
-          <p:cNvPr id="56" name="Rectangle 55">
-            <a:extLst>
-              <a:ext uri="{FF2B5EF4-FFF2-40B4-BE49-F238E27FC236}">
-                <a16:creationId xmlns:a16="http://schemas.microsoft.com/office/drawing/2014/main" id="{20986E0A-8958-8D72-E0CD-55999BF1DD56}"/>
-              </a:ext>
-            </a:extLst>
-          </p:cNvPr>
-          <p:cNvSpPr/>
-          <p:nvPr/>
-        </p:nvSpPr>
-        <p:spPr>
-          <a:xfrm>
-            <a:off x="7868728" y="3628920"/>
-            <a:ext cx="1200508" cy="214225"/>
-          </a:xfrm>
-          <a:prstGeom prst="rect">
-            <a:avLst/>
-          </a:prstGeom>
-        </p:spPr>
-        <p:style>
-          <a:lnRef idx="2">
-            <a:schemeClr val="accent1">
-              <a:shade val="50000"/>
-            </a:schemeClr>
-          </a:lnRef>
-          <a:fillRef idx="1">
-            <a:schemeClr val="accent1"/>
-          </a:fillRef>
-          <a:effectRef idx="0">
-            <a:schemeClr val="accent1"/>
-          </a:effectRef>
-          <a:fontRef idx="minor">
-            <a:schemeClr val="lt1"/>
-          </a:fontRef>
-        </p:style>
-        <p:txBody>
-          <a:bodyPr rtlCol="0" anchor="ctr"/>
-          <a:lstStyle/>
-          <a:p>
-            <a:pPr algn="ctr"/>
-            <a:r>
-              <a:rPr lang="de-AT" sz="1200" dirty="0"/>
-              <a:t>Lastprofil</a:t>
-            </a:r>
-          </a:p>
-        </p:txBody>
-      </p:sp>
-      <p:sp>
-        <p:nvSpPr>
-          <p:cNvPr id="57" name="Rectangle 56">
-            <a:extLst>
-              <a:ext uri="{FF2B5EF4-FFF2-40B4-BE49-F238E27FC236}">
-                <a16:creationId xmlns:a16="http://schemas.microsoft.com/office/drawing/2014/main" id="{08D9C96A-3124-BFE8-AF42-522ECEE0B434}"/>
-              </a:ext>
-            </a:extLst>
-          </p:cNvPr>
-          <p:cNvSpPr/>
-          <p:nvPr/>
-        </p:nvSpPr>
-        <p:spPr>
-          <a:xfrm>
-            <a:off x="7868728" y="3886270"/>
-            <a:ext cx="1200508" cy="214225"/>
-          </a:xfrm>
-          <a:prstGeom prst="rect">
-            <a:avLst/>
-          </a:prstGeom>
-        </p:spPr>
-        <p:style>
-          <a:lnRef idx="2">
-            <a:schemeClr val="accent1">
-              <a:shade val="50000"/>
-            </a:schemeClr>
-          </a:lnRef>
-          <a:fillRef idx="1">
-            <a:schemeClr val="accent1"/>
-          </a:fillRef>
-          <a:effectRef idx="0">
-            <a:schemeClr val="accent1"/>
-          </a:effectRef>
-          <a:fontRef idx="minor">
-            <a:schemeClr val="lt1"/>
-          </a:fontRef>
-        </p:style>
-        <p:txBody>
-          <a:bodyPr rtlCol="0" anchor="ctr"/>
-          <a:lstStyle/>
-          <a:p>
-            <a:pPr algn="ctr"/>
-            <a:r>
-              <a:rPr lang="de-AT" sz="1200" dirty="0"/>
-              <a:t>Flexibilität</a:t>
-            </a:r>
-          </a:p>
-        </p:txBody>
-      </p:sp>
-      <p:cxnSp>
-        <p:nvCxnSpPr>
-          <p:cNvPr id="58" name="Straight Arrow Connector 57">
-            <a:extLst>
-              <a:ext uri="{FF2B5EF4-FFF2-40B4-BE49-F238E27FC236}">
-                <a16:creationId xmlns:a16="http://schemas.microsoft.com/office/drawing/2014/main" id="{0A5E6219-4D63-229E-7824-F95DD42DD1AA}"/>
-              </a:ext>
-            </a:extLst>
-          </p:cNvPr>
-          <p:cNvCxnSpPr>
-            <a:cxnSpLocks/>
-            <a:stCxn id="56" idx="1"/>
-          </p:cNvCxnSpPr>
-          <p:nvPr/>
-        </p:nvCxnSpPr>
-        <p:spPr>
-          <a:xfrm flipH="1">
-            <a:off x="6824932" y="3736033"/>
-            <a:ext cx="1043796" cy="0"/>
-          </a:xfrm>
-          <a:prstGeom prst="straightConnector1">
-            <a:avLst/>
-          </a:prstGeom>
-          <a:ln>
-            <a:tailEnd type="triangle"/>
-          </a:ln>
-        </p:spPr>
-        <p:style>
-          <a:lnRef idx="1">
-            <a:schemeClr val="accent1"/>
-          </a:lnRef>
-          <a:fillRef idx="0">
-            <a:schemeClr val="accent1"/>
-          </a:fillRef>
-          <a:effectRef idx="0">
-            <a:schemeClr val="accent1"/>
-          </a:effectRef>
-          <a:fontRef idx="minor">
-            <a:schemeClr val="tx1"/>
-          </a:fontRef>
-        </p:style>
-      </p:cxnSp>
-      <p:cxnSp>
-        <p:nvCxnSpPr>
-          <p:cNvPr id="59" name="Straight Arrow Connector 58">
-            <a:extLst>
-              <a:ext uri="{FF2B5EF4-FFF2-40B4-BE49-F238E27FC236}">
-                <a16:creationId xmlns:a16="http://schemas.microsoft.com/office/drawing/2014/main" id="{509B433A-EFEB-288D-4640-E4801AE7E0C4}"/>
-              </a:ext>
-            </a:extLst>
-          </p:cNvPr>
-          <p:cNvCxnSpPr>
-            <a:cxnSpLocks/>
-            <a:endCxn id="63" idx="1"/>
-          </p:cNvCxnSpPr>
-          <p:nvPr/>
-        </p:nvCxnSpPr>
-        <p:spPr>
-          <a:xfrm>
-            <a:off x="6824932" y="4249903"/>
-            <a:ext cx="1043796" cy="0"/>
-          </a:xfrm>
-          <a:prstGeom prst="straightConnector1">
-            <a:avLst/>
-          </a:prstGeom>
-          <a:ln>
-            <a:tailEnd type="triangle"/>
-          </a:ln>
-        </p:spPr>
-        <p:style>
-          <a:lnRef idx="1">
-            <a:schemeClr val="accent1"/>
-          </a:lnRef>
-          <a:fillRef idx="0">
-            <a:schemeClr val="accent1"/>
-          </a:fillRef>
-          <a:effectRef idx="0">
-            <a:schemeClr val="accent1"/>
-          </a:effectRef>
-          <a:fontRef idx="minor">
-            <a:schemeClr val="tx1"/>
-          </a:fontRef>
-        </p:style>
-      </p:cxnSp>
-      <p:sp>
-        <p:nvSpPr>
-          <p:cNvPr id="60" name="TextBox 59">
-            <a:extLst>
-              <a:ext uri="{FF2B5EF4-FFF2-40B4-BE49-F238E27FC236}">
-                <a16:creationId xmlns:a16="http://schemas.microsoft.com/office/drawing/2014/main" id="{F7B5A1C0-F2D2-2B91-AFE5-5F73B8B862B7}"/>
-              </a:ext>
-            </a:extLst>
-          </p:cNvPr>
-          <p:cNvSpPr txBox="1"/>
-          <p:nvPr/>
-        </p:nvSpPr>
-        <p:spPr>
-          <a:xfrm>
-            <a:off x="7002852" y="3526269"/>
-            <a:ext cx="687956" cy="261610"/>
-          </a:xfrm>
-          <a:prstGeom prst="rect">
-            <a:avLst/>
-          </a:prstGeom>
-          <a:noFill/>
-        </p:spPr>
-        <p:txBody>
-          <a:bodyPr wrap="square" rtlCol="0">
-            <a:spAutoFit/>
-          </a:bodyPr>
-          <a:lstStyle/>
-          <a:p>
-            <a:r>
-              <a:rPr lang="de-AT" sz="1100" dirty="0"/>
-              <a:t>2 kWh</a:t>
-            </a:r>
-          </a:p>
-        </p:txBody>
-      </p:sp>
-      <p:sp>
-        <p:nvSpPr>
-          <p:cNvPr id="61" name="TextBox 60">
-            <a:extLst>
-              <a:ext uri="{FF2B5EF4-FFF2-40B4-BE49-F238E27FC236}">
-                <a16:creationId xmlns:a16="http://schemas.microsoft.com/office/drawing/2014/main" id="{86610781-DCB8-FE77-E141-5EABBC5FA45D}"/>
-              </a:ext>
-            </a:extLst>
-          </p:cNvPr>
-          <p:cNvSpPr txBox="1"/>
-          <p:nvPr/>
-        </p:nvSpPr>
-        <p:spPr>
-          <a:xfrm>
-            <a:off x="7002852" y="4217856"/>
-            <a:ext cx="687956" cy="261610"/>
-          </a:xfrm>
-          <a:prstGeom prst="rect">
-            <a:avLst/>
-          </a:prstGeom>
-          <a:noFill/>
-        </p:spPr>
-        <p:txBody>
-          <a:bodyPr wrap="square" rtlCol="0">
-            <a:spAutoFit/>
-          </a:bodyPr>
-          <a:lstStyle/>
-          <a:p>
-            <a:r>
-              <a:rPr lang="de-AT" sz="1100" dirty="0"/>
-              <a:t>0 Wh</a:t>
-            </a:r>
-          </a:p>
-        </p:txBody>
-      </p:sp>
-      <p:sp>
-        <p:nvSpPr>
-          <p:cNvPr id="62" name="TextBox 61">
-            <a:extLst>
-              <a:ext uri="{FF2B5EF4-FFF2-40B4-BE49-F238E27FC236}">
-                <a16:creationId xmlns:a16="http://schemas.microsoft.com/office/drawing/2014/main" id="{9A1C9B9A-00AD-4C6B-CE2E-B86FA8CE5C95}"/>
-              </a:ext>
-            </a:extLst>
-          </p:cNvPr>
-          <p:cNvSpPr txBox="1"/>
-          <p:nvPr/>
-        </p:nvSpPr>
-        <p:spPr>
-          <a:xfrm>
-            <a:off x="9841300" y="3808301"/>
-            <a:ext cx="543464" cy="369332"/>
-          </a:xfrm>
-          <a:prstGeom prst="rect">
-            <a:avLst/>
-          </a:prstGeom>
-          <a:noFill/>
-        </p:spPr>
-        <p:txBody>
-          <a:bodyPr wrap="square" rtlCol="0">
-            <a:spAutoFit/>
-          </a:bodyPr>
-          <a:lstStyle/>
-          <a:p>
-            <a:r>
-              <a:rPr lang="de-AT" dirty="0"/>
-              <a:t>M3</a:t>
-            </a:r>
-          </a:p>
-        </p:txBody>
-      </p:sp>
-      <p:sp>
-        <p:nvSpPr>
-          <p:cNvPr id="63" name="Rectangle 62">
-            <a:extLst>
-              <a:ext uri="{FF2B5EF4-FFF2-40B4-BE49-F238E27FC236}">
-                <a16:creationId xmlns:a16="http://schemas.microsoft.com/office/drawing/2014/main" id="{D2C278D0-A85A-2A8F-3CD8-78F284702920}"/>
-              </a:ext>
-            </a:extLst>
-          </p:cNvPr>
-          <p:cNvSpPr/>
-          <p:nvPr/>
-        </p:nvSpPr>
-        <p:spPr>
-          <a:xfrm>
-            <a:off x="7868728" y="4142790"/>
-            <a:ext cx="1200508" cy="214225"/>
-          </a:xfrm>
-          <a:prstGeom prst="rect">
-            <a:avLst/>
-          </a:prstGeom>
-        </p:spPr>
-        <p:style>
-          <a:lnRef idx="2">
-            <a:schemeClr val="accent1">
-              <a:shade val="50000"/>
-            </a:schemeClr>
-          </a:lnRef>
-          <a:fillRef idx="1">
-            <a:schemeClr val="accent1"/>
-          </a:fillRef>
-          <a:effectRef idx="0">
-            <a:schemeClr val="accent1"/>
-          </a:effectRef>
-          <a:fontRef idx="minor">
-            <a:schemeClr val="lt1"/>
-          </a:fontRef>
-        </p:style>
-        <p:txBody>
-          <a:bodyPr rtlCol="0" anchor="ctr"/>
-          <a:lstStyle/>
-          <a:p>
-            <a:pPr algn="ctr"/>
-            <a:r>
-              <a:rPr lang="de-AT" sz="1200" dirty="0"/>
-              <a:t>Zuspruch</a:t>
-            </a:r>
-          </a:p>
-        </p:txBody>
-      </p:sp>
-      <p:cxnSp>
-        <p:nvCxnSpPr>
-          <p:cNvPr id="64" name="Straight Arrow Connector 63">
-            <a:extLst>
-              <a:ext uri="{FF2B5EF4-FFF2-40B4-BE49-F238E27FC236}">
-                <a16:creationId xmlns:a16="http://schemas.microsoft.com/office/drawing/2014/main" id="{6F4012D0-0B7F-2B1F-B4B6-7CD68BA92370}"/>
-              </a:ext>
-            </a:extLst>
-          </p:cNvPr>
-          <p:cNvCxnSpPr>
-            <a:cxnSpLocks/>
-          </p:cNvCxnSpPr>
-          <p:nvPr/>
-        </p:nvCxnSpPr>
-        <p:spPr>
-          <a:xfrm flipH="1">
-            <a:off x="6824932" y="3994285"/>
-            <a:ext cx="1043796" cy="0"/>
-          </a:xfrm>
-          <a:prstGeom prst="straightConnector1">
-            <a:avLst/>
-          </a:prstGeom>
-          <a:ln>
-            <a:tailEnd type="triangle"/>
-          </a:ln>
-        </p:spPr>
-        <p:style>
-          <a:lnRef idx="1">
-            <a:schemeClr val="accent1"/>
-          </a:lnRef>
-          <a:fillRef idx="0">
-            <a:schemeClr val="accent1"/>
-          </a:fillRef>
-          <a:effectRef idx="0">
-            <a:schemeClr val="accent1"/>
-          </a:effectRef>
-          <a:fontRef idx="minor">
-            <a:schemeClr val="tx1"/>
-          </a:fontRef>
-        </p:style>
-      </p:cxnSp>
-      <p:sp>
-        <p:nvSpPr>
-          <p:cNvPr id="65" name="TextBox 64">
-            <a:extLst>
-              <a:ext uri="{FF2B5EF4-FFF2-40B4-BE49-F238E27FC236}">
-                <a16:creationId xmlns:a16="http://schemas.microsoft.com/office/drawing/2014/main" id="{C9472CD2-0069-5A7B-87AF-CC9451383EFC}"/>
-              </a:ext>
-            </a:extLst>
-          </p:cNvPr>
-          <p:cNvSpPr txBox="1"/>
-          <p:nvPr/>
-        </p:nvSpPr>
-        <p:spPr>
-          <a:xfrm>
-            <a:off x="7002852" y="3778171"/>
-            <a:ext cx="687956" cy="261610"/>
-          </a:xfrm>
-          <a:prstGeom prst="rect">
-            <a:avLst/>
-          </a:prstGeom>
-          <a:noFill/>
-        </p:spPr>
-        <p:txBody>
-          <a:bodyPr wrap="square" rtlCol="0">
-            <a:spAutoFit/>
-          </a:bodyPr>
-          <a:lstStyle/>
-          <a:p>
-            <a:r>
-              <a:rPr lang="de-AT" sz="1100" dirty="0">
-                <a:solidFill>
-                  <a:srgbClr val="00B050"/>
-                </a:solidFill>
-              </a:rPr>
-              <a:t>-1 kWh</a:t>
-            </a:r>
-          </a:p>
-        </p:txBody>
-      </p:sp>
-      <p:sp>
-        <p:nvSpPr>
-          <p:cNvPr id="66" name="Action Button: Go Home 65">
-            <a:hlinkClick r:id="" action="ppaction://noaction" highlightClick="1"/>
-            <a:extLst>
-              <a:ext uri="{FF2B5EF4-FFF2-40B4-BE49-F238E27FC236}">
-                <a16:creationId xmlns:a16="http://schemas.microsoft.com/office/drawing/2014/main" id="{C3A9834A-007C-C130-EEF1-A729BDA3DAC4}"/>
-              </a:ext>
-            </a:extLst>
-          </p:cNvPr>
-          <p:cNvSpPr/>
-          <p:nvPr/>
-        </p:nvSpPr>
-        <p:spPr>
-          <a:xfrm>
-            <a:off x="9138969" y="4797443"/>
-            <a:ext cx="655608" cy="728095"/>
-          </a:xfrm>
-          <a:prstGeom prst="actionButtonHome">
-            <a:avLst/>
-          </a:prstGeom>
-        </p:spPr>
-        <p:style>
-          <a:lnRef idx="2">
-            <a:schemeClr val="accent1">
-              <a:shade val="50000"/>
-            </a:schemeClr>
-          </a:lnRef>
-          <a:fillRef idx="1">
-            <a:schemeClr val="accent1"/>
-          </a:fillRef>
-          <a:effectRef idx="0">
-            <a:schemeClr val="accent1"/>
-          </a:effectRef>
-          <a:fontRef idx="minor">
-            <a:schemeClr val="lt1"/>
-          </a:fontRef>
-        </p:style>
-        <p:txBody>
-          <a:bodyPr rtlCol="0" anchor="ctr"/>
-          <a:lstStyle/>
-          <a:p>
-            <a:pPr algn="ctr"/>
-            <a:endParaRPr lang="de-AT"/>
-          </a:p>
-        </p:txBody>
-      </p:sp>
-      <p:sp>
-        <p:nvSpPr>
-          <p:cNvPr id="67" name="Rectangle 66">
-            <a:extLst>
-              <a:ext uri="{FF2B5EF4-FFF2-40B4-BE49-F238E27FC236}">
-                <a16:creationId xmlns:a16="http://schemas.microsoft.com/office/drawing/2014/main" id="{DE49936C-8B14-82EF-96B5-AB7AEA553997}"/>
-              </a:ext>
-            </a:extLst>
-          </p:cNvPr>
-          <p:cNvSpPr/>
-          <p:nvPr/>
-        </p:nvSpPr>
-        <p:spPr>
-          <a:xfrm>
-            <a:off x="7868728" y="4797443"/>
-            <a:ext cx="1200508" cy="214225"/>
-          </a:xfrm>
-          <a:prstGeom prst="rect">
-            <a:avLst/>
-          </a:prstGeom>
-        </p:spPr>
-        <p:style>
-          <a:lnRef idx="2">
-            <a:schemeClr val="accent1">
-              <a:shade val="50000"/>
-            </a:schemeClr>
-          </a:lnRef>
-          <a:fillRef idx="1">
-            <a:schemeClr val="accent1"/>
-          </a:fillRef>
-          <a:effectRef idx="0">
-            <a:schemeClr val="accent1"/>
-          </a:effectRef>
-          <a:fontRef idx="minor">
-            <a:schemeClr val="lt1"/>
-          </a:fontRef>
-        </p:style>
-        <p:txBody>
-          <a:bodyPr rtlCol="0" anchor="ctr"/>
-          <a:lstStyle/>
-          <a:p>
-            <a:pPr algn="ctr"/>
-            <a:r>
-              <a:rPr lang="de-AT" sz="1200" dirty="0"/>
-              <a:t>Lastprofil</a:t>
-            </a:r>
-          </a:p>
-        </p:txBody>
-      </p:sp>
-      <p:sp>
-        <p:nvSpPr>
-          <p:cNvPr id="68" name="Rectangle 67">
-            <a:extLst>
-              <a:ext uri="{FF2B5EF4-FFF2-40B4-BE49-F238E27FC236}">
-                <a16:creationId xmlns:a16="http://schemas.microsoft.com/office/drawing/2014/main" id="{696EEFBD-0940-597B-F3C6-51B4F7FE79F8}"/>
-              </a:ext>
-            </a:extLst>
-          </p:cNvPr>
-          <p:cNvSpPr/>
-          <p:nvPr/>
-        </p:nvSpPr>
-        <p:spPr>
-          <a:xfrm>
-            <a:off x="7868728" y="5054793"/>
-            <a:ext cx="1200508" cy="214225"/>
-          </a:xfrm>
-          <a:prstGeom prst="rect">
-            <a:avLst/>
-          </a:prstGeom>
-        </p:spPr>
-        <p:style>
-          <a:lnRef idx="2">
-            <a:schemeClr val="accent1">
-              <a:shade val="50000"/>
-            </a:schemeClr>
-          </a:lnRef>
-          <a:fillRef idx="1">
-            <a:schemeClr val="accent1"/>
-          </a:fillRef>
-          <a:effectRef idx="0">
-            <a:schemeClr val="accent1"/>
-          </a:effectRef>
-          <a:fontRef idx="minor">
-            <a:schemeClr val="lt1"/>
-          </a:fontRef>
-        </p:style>
-        <p:txBody>
-          <a:bodyPr rtlCol="0" anchor="ctr"/>
-          <a:lstStyle/>
-          <a:p>
-            <a:pPr algn="ctr"/>
-            <a:r>
-              <a:rPr lang="de-AT" sz="1200" dirty="0"/>
-              <a:t>Flexibilität</a:t>
-            </a:r>
-          </a:p>
-        </p:txBody>
-      </p:sp>
-      <p:cxnSp>
-        <p:nvCxnSpPr>
-          <p:cNvPr id="70" name="Straight Arrow Connector 69">
-            <a:extLst>
-              <a:ext uri="{FF2B5EF4-FFF2-40B4-BE49-F238E27FC236}">
-                <a16:creationId xmlns:a16="http://schemas.microsoft.com/office/drawing/2014/main" id="{E99931F6-4146-62A2-51D7-0CCB5EC87E41}"/>
-              </a:ext>
-            </a:extLst>
-          </p:cNvPr>
-          <p:cNvCxnSpPr>
-            <a:cxnSpLocks/>
-            <a:stCxn id="67" idx="1"/>
-          </p:cNvCxnSpPr>
-          <p:nvPr/>
-        </p:nvCxnSpPr>
-        <p:spPr>
-          <a:xfrm flipH="1">
-            <a:off x="6824932" y="4904556"/>
-            <a:ext cx="1043796" cy="0"/>
-          </a:xfrm>
-          <a:prstGeom prst="straightConnector1">
-            <a:avLst/>
-          </a:prstGeom>
-          <a:ln>
-            <a:tailEnd type="triangle"/>
-          </a:ln>
-        </p:spPr>
-        <p:style>
-          <a:lnRef idx="1">
-            <a:schemeClr val="accent1"/>
-          </a:lnRef>
-          <a:fillRef idx="0">
-            <a:schemeClr val="accent1"/>
-          </a:fillRef>
-          <a:effectRef idx="0">
-            <a:schemeClr val="accent1"/>
-          </a:effectRef>
-          <a:fontRef idx="minor">
-            <a:schemeClr val="tx1"/>
-          </a:fontRef>
-        </p:style>
-      </p:cxnSp>
-      <p:cxnSp>
-        <p:nvCxnSpPr>
-          <p:cNvPr id="97" name="Straight Arrow Connector 96">
-            <a:extLst>
-              <a:ext uri="{FF2B5EF4-FFF2-40B4-BE49-F238E27FC236}">
-                <a16:creationId xmlns:a16="http://schemas.microsoft.com/office/drawing/2014/main" id="{5DACC7ED-6B21-A977-FE11-F3C2E64A3391}"/>
-              </a:ext>
-            </a:extLst>
-          </p:cNvPr>
-          <p:cNvCxnSpPr>
-            <a:cxnSpLocks/>
-            <a:endCxn id="101" idx="1"/>
-          </p:cNvCxnSpPr>
-          <p:nvPr/>
-        </p:nvCxnSpPr>
-        <p:spPr>
-          <a:xfrm>
-            <a:off x="6824932" y="5418426"/>
-            <a:ext cx="1043796" cy="0"/>
-          </a:xfrm>
-          <a:prstGeom prst="straightConnector1">
-            <a:avLst/>
-          </a:prstGeom>
-          <a:ln>
-            <a:tailEnd type="triangle"/>
-          </a:ln>
-        </p:spPr>
-        <p:style>
-          <a:lnRef idx="1">
-            <a:schemeClr val="accent1"/>
-          </a:lnRef>
-          <a:fillRef idx="0">
-            <a:schemeClr val="accent1"/>
-          </a:fillRef>
-          <a:effectRef idx="0">
-            <a:schemeClr val="accent1"/>
-          </a:effectRef>
-          <a:fontRef idx="minor">
-            <a:schemeClr val="tx1"/>
-          </a:fontRef>
-        </p:style>
-      </p:cxnSp>
-      <p:sp>
-        <p:nvSpPr>
-          <p:cNvPr id="98" name="TextBox 97">
-            <a:extLst>
-              <a:ext uri="{FF2B5EF4-FFF2-40B4-BE49-F238E27FC236}">
-                <a16:creationId xmlns:a16="http://schemas.microsoft.com/office/drawing/2014/main" id="{E93C422F-6494-08F3-B97B-E77D6F890055}"/>
-              </a:ext>
-            </a:extLst>
-          </p:cNvPr>
-          <p:cNvSpPr txBox="1"/>
-          <p:nvPr/>
-        </p:nvSpPr>
-        <p:spPr>
-          <a:xfrm>
-            <a:off x="7002852" y="4694792"/>
-            <a:ext cx="687956" cy="261610"/>
-          </a:xfrm>
-          <a:prstGeom prst="rect">
-            <a:avLst/>
-          </a:prstGeom>
-          <a:noFill/>
-        </p:spPr>
-        <p:txBody>
-          <a:bodyPr wrap="square" rtlCol="0">
-            <a:spAutoFit/>
-          </a:bodyPr>
-          <a:lstStyle/>
-          <a:p>
-            <a:r>
-              <a:rPr lang="de-AT" sz="1100" dirty="0"/>
-              <a:t>12 kWh</a:t>
-            </a:r>
-          </a:p>
-        </p:txBody>
-      </p:sp>
-      <p:sp>
-        <p:nvSpPr>
-          <p:cNvPr id="99" name="TextBox 98">
-            <a:extLst>
-              <a:ext uri="{FF2B5EF4-FFF2-40B4-BE49-F238E27FC236}">
-                <a16:creationId xmlns:a16="http://schemas.microsoft.com/office/drawing/2014/main" id="{629F4353-F627-7C8B-F6BB-AFD0A2C3C537}"/>
-              </a:ext>
-            </a:extLst>
-          </p:cNvPr>
-          <p:cNvSpPr txBox="1"/>
-          <p:nvPr/>
-        </p:nvSpPr>
-        <p:spPr>
-          <a:xfrm>
-            <a:off x="7002852" y="5386379"/>
-            <a:ext cx="687956" cy="261610"/>
-          </a:xfrm>
-          <a:prstGeom prst="rect">
-            <a:avLst/>
-          </a:prstGeom>
-          <a:noFill/>
-        </p:spPr>
-        <p:txBody>
-          <a:bodyPr wrap="square" rtlCol="0">
-            <a:spAutoFit/>
-          </a:bodyPr>
-          <a:lstStyle/>
-          <a:p>
-            <a:r>
-              <a:rPr lang="de-AT" sz="1100" dirty="0"/>
-              <a:t>0 Wh</a:t>
-            </a:r>
-          </a:p>
-        </p:txBody>
-      </p:sp>
-      <p:sp>
-        <p:nvSpPr>
-          <p:cNvPr id="100" name="TextBox 99">
-            <a:extLst>
-              <a:ext uri="{FF2B5EF4-FFF2-40B4-BE49-F238E27FC236}">
-                <a16:creationId xmlns:a16="http://schemas.microsoft.com/office/drawing/2014/main" id="{4AF32464-AC51-6695-3E31-025D017121CB}"/>
-              </a:ext>
-            </a:extLst>
-          </p:cNvPr>
-          <p:cNvSpPr txBox="1"/>
-          <p:nvPr/>
-        </p:nvSpPr>
-        <p:spPr>
-          <a:xfrm>
-            <a:off x="9841300" y="4976824"/>
-            <a:ext cx="543464" cy="369332"/>
-          </a:xfrm>
-          <a:prstGeom prst="rect">
-            <a:avLst/>
-          </a:prstGeom>
-          <a:noFill/>
-        </p:spPr>
-        <p:txBody>
-          <a:bodyPr wrap="square" rtlCol="0">
-            <a:spAutoFit/>
-          </a:bodyPr>
-          <a:lstStyle/>
-          <a:p>
-            <a:r>
-              <a:rPr lang="de-AT" dirty="0"/>
-              <a:t>M4</a:t>
-            </a:r>
-          </a:p>
-        </p:txBody>
-      </p:sp>
-      <p:sp>
-        <p:nvSpPr>
-          <p:cNvPr id="101" name="Rectangle 100">
-            <a:extLst>
-              <a:ext uri="{FF2B5EF4-FFF2-40B4-BE49-F238E27FC236}">
-                <a16:creationId xmlns:a16="http://schemas.microsoft.com/office/drawing/2014/main" id="{41D5F357-14F0-ED66-6ECD-34DBF4341495}"/>
-              </a:ext>
-            </a:extLst>
-          </p:cNvPr>
-          <p:cNvSpPr/>
-          <p:nvPr/>
-        </p:nvSpPr>
-        <p:spPr>
-          <a:xfrm>
-            <a:off x="7868728" y="5311313"/>
-            <a:ext cx="1200508" cy="214225"/>
-          </a:xfrm>
-          <a:prstGeom prst="rect">
-            <a:avLst/>
-          </a:prstGeom>
-        </p:spPr>
-        <p:style>
-          <a:lnRef idx="2">
-            <a:schemeClr val="accent1">
-              <a:shade val="50000"/>
-            </a:schemeClr>
-          </a:lnRef>
-          <a:fillRef idx="1">
-            <a:schemeClr val="accent1"/>
-          </a:fillRef>
-          <a:effectRef idx="0">
-            <a:schemeClr val="accent1"/>
-          </a:effectRef>
-          <a:fontRef idx="minor">
-            <a:schemeClr val="lt1"/>
-          </a:fontRef>
-        </p:style>
-        <p:txBody>
-          <a:bodyPr rtlCol="0" anchor="ctr"/>
-          <a:lstStyle/>
-          <a:p>
-            <a:pPr algn="ctr"/>
-            <a:r>
-              <a:rPr lang="de-AT" sz="1200" dirty="0"/>
-              <a:t>Zuspruch</a:t>
-            </a:r>
-          </a:p>
-        </p:txBody>
-      </p:sp>
-      <p:cxnSp>
-        <p:nvCxnSpPr>
-          <p:cNvPr id="102" name="Straight Arrow Connector 101">
-            <a:extLst>
-              <a:ext uri="{FF2B5EF4-FFF2-40B4-BE49-F238E27FC236}">
-                <a16:creationId xmlns:a16="http://schemas.microsoft.com/office/drawing/2014/main" id="{C0616B9E-8D2C-6624-0F57-1FFBF5534B5F}"/>
-              </a:ext>
-            </a:extLst>
-          </p:cNvPr>
-          <p:cNvCxnSpPr>
-            <a:cxnSpLocks/>
-          </p:cNvCxnSpPr>
-          <p:nvPr/>
-        </p:nvCxnSpPr>
-        <p:spPr>
-          <a:xfrm flipH="1">
-            <a:off x="6824932" y="5162808"/>
-            <a:ext cx="1043796" cy="0"/>
-          </a:xfrm>
-          <a:prstGeom prst="straightConnector1">
-            <a:avLst/>
-          </a:prstGeom>
-          <a:ln>
-            <a:tailEnd type="triangle"/>
-          </a:ln>
-        </p:spPr>
-        <p:style>
-          <a:lnRef idx="1">
-            <a:schemeClr val="accent1"/>
-          </a:lnRef>
-          <a:fillRef idx="0">
-            <a:schemeClr val="accent1"/>
-          </a:fillRef>
-          <a:effectRef idx="0">
-            <a:schemeClr val="accent1"/>
-          </a:effectRef>
-          <a:fontRef idx="minor">
-            <a:schemeClr val="tx1"/>
-          </a:fontRef>
-        </p:style>
-      </p:cxnSp>
-      <p:sp>
-        <p:nvSpPr>
-          <p:cNvPr id="103" name="TextBox 102">
-            <a:extLst>
-              <a:ext uri="{FF2B5EF4-FFF2-40B4-BE49-F238E27FC236}">
-                <a16:creationId xmlns:a16="http://schemas.microsoft.com/office/drawing/2014/main" id="{55D32FEE-3B54-EDD3-89CA-F1ACD73DB0BC}"/>
-              </a:ext>
-            </a:extLst>
-          </p:cNvPr>
-          <p:cNvSpPr txBox="1"/>
-          <p:nvPr/>
-        </p:nvSpPr>
-        <p:spPr>
-          <a:xfrm>
-            <a:off x="7002852" y="4946694"/>
-            <a:ext cx="687956" cy="261610"/>
-          </a:xfrm>
-          <a:prstGeom prst="rect">
-            <a:avLst/>
-          </a:prstGeom>
-          <a:noFill/>
-        </p:spPr>
-        <p:txBody>
-          <a:bodyPr wrap="square" rtlCol="0">
-            <a:spAutoFit/>
-          </a:bodyPr>
-          <a:lstStyle/>
-          <a:p>
-            <a:r>
-              <a:rPr lang="de-AT" sz="1100" dirty="0">
-                <a:solidFill>
-                  <a:srgbClr val="00B050"/>
-                </a:solidFill>
-              </a:rPr>
-              <a:t>-3 kWh</a:t>
-            </a:r>
-          </a:p>
-        </p:txBody>
-      </p:sp>
-    </p:spTree>
-    <p:extLst>
-      <p:ext uri="{BB962C8B-B14F-4D97-AF65-F5344CB8AC3E}">
-        <p14:creationId xmlns:p14="http://schemas.microsoft.com/office/powerpoint/2010/main" val="1940334753"/>
       </p:ext>
     </p:extLst>
   </p:cSld>

</xml_diff>